<commit_message>
Results section from audited data: generated tables, number macros, six-language figures, corpus and failure sunbursts; Algerian removed
Co-Authored-By: Claude Fable 5.1 <noreply@anthropic.com>
</commit_message>
<xml_diff>
--- a/figures/figures.pptx
+++ b/figures/figures.pptx
@@ -1279,7 +1279,7 @@
                 <a:ea typeface="Calibri" pitchFamily="34" charset="-122"/>
                 <a:cs typeface="Calibri" pitchFamily="34" charset="-120"/>
               </a:rPr>
-              <a:t>The same task is also translated to Egyptian, Syrian, Qatari, Sudanese and Algerian Arabic.</a:t>
+              <a:t>The same task is also translated to Egyptian, Syrian, Qatari and Sudanese Arabic.</a:t>
             </a:r>
             <a:endParaRPr lang="en-US" sz="900" dirty="0"/>
           </a:p>
@@ -2410,7 +2410,7 @@
                 <a:ea typeface="Calibri" pitchFamily="34" charset="-122"/>
                 <a:cs typeface="Calibri" pitchFamily="34" charset="-120"/>
               </a:rPr>
-              <a:t>Translated by humans to MSA and 5 dialects: Egyptian, Syrian, Qatari, Sudanese, Algerian</a:t>
+              <a:t>Translated by humans to MSA and 4 dialects: Egyptian, Syrian, Qatari, Sudanese</a:t>
             </a:r>
             <a:endParaRPr lang="en-US" sz="850" dirty="0"/>
           </a:p>

</xml_diff>

<commit_message>
Algerian shown as an empty (not delivered) column in every language figure and table
Co-Authored-By: Claude Fable 5.1 <noreply@anthropic.com>
</commit_message>
<xml_diff>
--- a/figures/figures.pptx
+++ b/figures/figures.pptx
@@ -1279,7 +1279,7 @@
                 <a:ea typeface="Calibri" pitchFamily="34" charset="-122"/>
                 <a:cs typeface="Calibri" pitchFamily="34" charset="-120"/>
               </a:rPr>
-              <a:t>The same task is also translated to Egyptian, Syrian, Qatari and Sudanese Arabic.</a:t>
+              <a:t>The same task is also translated to Egyptian, Syrian, Qatari, Sudanese and Algerian Arabic.</a:t>
             </a:r>
             <a:endParaRPr lang="en-US" sz="900" dirty="0"/>
           </a:p>
@@ -2410,7 +2410,7 @@
                 <a:ea typeface="Calibri" pitchFamily="34" charset="-122"/>
                 <a:cs typeface="Calibri" pitchFamily="34" charset="-120"/>
               </a:rPr>
-              <a:t>Translated by humans to MSA and 4 dialects: Egyptian, Syrian, Qatari, Sudanese</a:t>
+              <a:t>Translated by humans to MSA and 5 dialects: Egyptian, Syrian, Qatari, Sudanese, Algerian</a:t>
             </a:r>
             <a:endParaRPr lang="en-US" sz="850" dirty="0"/>
           </a:p>

</xml_diff>